<commit_message>
adding example of indexed moving average chart
</commit_message>
<xml_diff>
--- a/EngineeredMonitoringPlatform/docs/EMP_PresentationSlides.pptx
+++ b/EngineeredMonitoringPlatform/docs/EMP_PresentationSlides.pptx
@@ -42,6 +42,7 @@
     <p:sldId id="293" r:id="rId36"/>
     <p:sldId id="295" r:id="rId37"/>
     <p:sldId id="289" r:id="rId38"/>
+    <p:sldId id="296" r:id="rId39"/>
   </p:sldIdLst>
   <p:sldSz cx="12192000" cy="6858000"/>
   <p:notesSz cx="6858000" cy="9144000"/>
@@ -6946,7 +6947,7 @@
               </a:lnSpc>
             </a:pPr>
             <a:r>
-              <a:rPr lang="en-CH" sz="2000" dirty="0"/>
+              <a:rPr lang="de-DE" sz="2000" dirty="0"/>
               <a:t>You have the possibility to show your data in various chart types: Line | Area | Bar | Scatter | Stepped Line | Stepped Area | Spark Line | Spark Bar | Pie | Doughnut | Radar | Polar</a:t>
             </a:r>
             <a:br>
@@ -8018,6 +8019,171 @@
     <p:extLst>
       <p:ext uri="{BB962C8B-B14F-4D97-AF65-F5344CB8AC3E}">
         <p14:creationId xmlns:p14="http://schemas.microsoft.com/office/powerpoint/2010/main" val="2214737594"/>
+      </p:ext>
+    </p:extLst>
+  </p:cSld>
+  <p:clrMapOvr>
+    <a:masterClrMapping/>
+  </p:clrMapOvr>
+</p:sld>
+</file>
+
+<file path=ppt/slides/slide38.xml><?xml version="1.0" encoding="utf-8"?>
+<p:sld xmlns:a="http://schemas.openxmlformats.org/drawingml/2006/main" xmlns:r="http://schemas.openxmlformats.org/officeDocument/2006/relationships" xmlns:p="http://schemas.openxmlformats.org/presentationml/2006/main">
+  <p:cSld>
+    <p:spTree>
+      <p:nvGrpSpPr>
+        <p:cNvPr id="1" name="">
+          <a:extLst>
+            <a:ext uri="{FF2B5EF4-FFF2-40B4-BE49-F238E27FC236}">
+              <a16:creationId xmlns:a16="http://schemas.microsoft.com/office/drawing/2014/main" id="{8068C59A-B73A-83D4-E40E-A040D5FE0EE8}"/>
+            </a:ext>
+          </a:extLst>
+        </p:cNvPr>
+        <p:cNvGrpSpPr/>
+        <p:nvPr/>
+      </p:nvGrpSpPr>
+      <p:grpSpPr>
+        <a:xfrm>
+          <a:off x="0" y="0"/>
+          <a:ext cx="0" cy="0"/>
+          <a:chOff x="0" y="0"/>
+          <a:chExt cx="0" cy="0"/>
+        </a:xfrm>
+      </p:grpSpPr>
+      <p:sp>
+        <p:nvSpPr>
+          <p:cNvPr id="2" name="Title 1">
+            <a:extLst>
+              <a:ext uri="{FF2B5EF4-FFF2-40B4-BE49-F238E27FC236}">
+                <a16:creationId xmlns:a16="http://schemas.microsoft.com/office/drawing/2014/main" id="{D037ED42-2C99-0816-C231-1BABAC5EDF04}"/>
+              </a:ext>
+            </a:extLst>
+          </p:cNvPr>
+          <p:cNvSpPr>
+            <a:spLocks noGrp="1"/>
+          </p:cNvSpPr>
+          <p:nvPr>
+            <p:ph type="title"/>
+          </p:nvPr>
+        </p:nvSpPr>
+        <p:spPr/>
+        <p:txBody>
+          <a:bodyPr/>
+          <a:lstStyle/>
+          <a:p>
+            <a:r>
+              <a:rPr lang="en-CH" dirty="0"/>
+              <a:t>Indexed Moving Average Charts</a:t>
+            </a:r>
+          </a:p>
+        </p:txBody>
+      </p:sp>
+      <p:sp>
+        <p:nvSpPr>
+          <p:cNvPr id="3" name="Content Placeholder 2">
+            <a:extLst>
+              <a:ext uri="{FF2B5EF4-FFF2-40B4-BE49-F238E27FC236}">
+                <a16:creationId xmlns:a16="http://schemas.microsoft.com/office/drawing/2014/main" id="{4365B736-5DF0-9E2A-AC44-C5E75C1F63C0}"/>
+              </a:ext>
+            </a:extLst>
+          </p:cNvPr>
+          <p:cNvSpPr>
+            <a:spLocks noGrp="1"/>
+          </p:cNvSpPr>
+          <p:nvPr>
+            <p:ph idx="1"/>
+          </p:nvPr>
+        </p:nvSpPr>
+        <p:spPr>
+          <a:xfrm>
+            <a:off x="838200" y="1180012"/>
+            <a:ext cx="10515600" cy="752475"/>
+          </a:xfrm>
+        </p:spPr>
+        <p:txBody>
+          <a:bodyPr>
+            <a:normAutofit fontScale="55000" lnSpcReduction="20000"/>
+          </a:bodyPr>
+          <a:lstStyle/>
+          <a:p>
+            <a:pPr>
+              <a:lnSpc>
+                <a:spcPct val="120000"/>
+              </a:lnSpc>
+            </a:pPr>
+            <a:r>
+              <a:rPr lang="en-GB" dirty="0"/>
+              <a:t>Index moving average charts can help to visualize changes in values more clearly when values are high. They show you the change in percentage instead of the absolute value, what makes it easier to understand the amount of change over time.</a:t>
+            </a:r>
+            <a:endParaRPr lang="en-CH" dirty="0"/>
+          </a:p>
+        </p:txBody>
+      </p:sp>
+      <p:pic>
+        <p:nvPicPr>
+          <p:cNvPr id="17" name="Picture 16">
+            <a:extLst>
+              <a:ext uri="{FF2B5EF4-FFF2-40B4-BE49-F238E27FC236}">
+                <a16:creationId xmlns:a16="http://schemas.microsoft.com/office/drawing/2014/main" id="{BA30730C-DDA4-BDE9-0C0C-4A1E776428E5}"/>
+              </a:ext>
+            </a:extLst>
+          </p:cNvPr>
+          <p:cNvPicPr>
+            <a:picLocks noChangeAspect="1"/>
+          </p:cNvPicPr>
+          <p:nvPr/>
+        </p:nvPicPr>
+        <p:blipFill>
+          <a:blip r:embed="rId2"/>
+          <a:stretch>
+            <a:fillRect/>
+          </a:stretch>
+        </p:blipFill>
+        <p:spPr>
+          <a:xfrm>
+            <a:off x="6096000" y="2028471"/>
+            <a:ext cx="3798441" cy="4394370"/>
+          </a:xfrm>
+          <a:prstGeom prst="rect">
+            <a:avLst/>
+          </a:prstGeom>
+        </p:spPr>
+      </p:pic>
+      <p:pic>
+        <p:nvPicPr>
+          <p:cNvPr id="21" name="Picture 20">
+            <a:extLst>
+              <a:ext uri="{FF2B5EF4-FFF2-40B4-BE49-F238E27FC236}">
+                <a16:creationId xmlns:a16="http://schemas.microsoft.com/office/drawing/2014/main" id="{20662E0F-8E56-6E4E-BEDD-C40367D5B269}"/>
+              </a:ext>
+            </a:extLst>
+          </p:cNvPr>
+          <p:cNvPicPr>
+            <a:picLocks noChangeAspect="1"/>
+          </p:cNvPicPr>
+          <p:nvPr/>
+        </p:nvPicPr>
+        <p:blipFill>
+          <a:blip r:embed="rId3"/>
+          <a:stretch>
+            <a:fillRect/>
+          </a:stretch>
+        </p:blipFill>
+        <p:spPr>
+          <a:xfrm>
+            <a:off x="1305547" y="1905099"/>
+            <a:ext cx="4311482" cy="4519683"/>
+          </a:xfrm>
+          <a:prstGeom prst="rect">
+            <a:avLst/>
+          </a:prstGeom>
+        </p:spPr>
+      </p:pic>
+    </p:spTree>
+    <p:extLst>
+      <p:ext uri="{BB962C8B-B14F-4D97-AF65-F5344CB8AC3E}">
+        <p14:creationId xmlns:p14="http://schemas.microsoft.com/office/powerpoint/2010/main" val="1075634210"/>
       </p:ext>
     </p:extLst>
   </p:cSld>

</xml_diff>